<commit_message>
Update founder names in company profile
Co-Authored-By: Claude Opus 5.5 <noreply@anthropic.com>
Claude-Session: https://claude.ai/code/session_015T4Ky8TkjrkT1kBowiQKVz
</commit_message>
<xml_diff>
--- a/fleetana-launch/brand/profile/Fleetana-Company-Profile-AR.pptx
+++ b/fleetana-launch/brand/profile/Fleetana-Company-Profile-AR.pptx
@@ -126,20 +126,20 @@
   <p:extLst>
     <p:ext uri="{521415D9-36F7-43E2-AB2F-B90AF26B5E84}">
       <p14:sectionLst xmlns:p14="http://schemas.microsoft.com/office/powerpoint/2010/main">
-        <p14:section name="من نحن" id="{57395a9d-14c3-f18e-c621-2c9f6e61592f}">
+        <p14:section name="من نحن" id="{ad9eec1e-00cc-dc2d-be3d-70b6fdbcd315}">
           <p14:sldIdLst>
             <p14:sldId id="256"/>
             <p14:sldId id="257"/>
             <p14:sldId id="258"/>
           </p14:sldIdLst>
         </p14:section>
-        <p14:section name="المشكلة" id="{5db43ae1-a80b-3bae-6572-fdb2105eb4ed}">
+        <p14:section name="المشكلة" id="{bed8a8db-4aeb-ef97-360e-c7803c08a1f3}">
           <p14:sldIdLst>
             <p14:sldId id="259"/>
             <p14:sldId id="260"/>
           </p14:sldIdLst>
         </p14:section>
-        <p14:section name="الحل" id="{1b5a527d-ec50-5f2a-2d1f-3eb630576391}">
+        <p14:section name="الحل" id="{802bccb6-4771-9157-e82f-036942c27e99}">
           <p14:sldIdLst>
             <p14:sldId id="261"/>
             <p14:sldId id="262"/>
@@ -150,20 +150,20 @@
             <p14:sldId id="267"/>
           </p14:sldIdLst>
         </p14:section>
-        <p14:section name="أجهزة التتبع" id="{b78ea642-ae7f-d3be-8503-075e2a73db6d}">
+        <p14:section name="أجهزة التتبع" id="{167f20a3-c95b-d774-4076-07c63d30a3f9}">
           <p14:sldIdLst>
             <p14:sldId id="268"/>
             <p14:sldId id="269"/>
             <p14:sldId id="270"/>
           </p14:sldIdLst>
         </p14:section>
-        <p14:section name="التوفير" id="{f56f2117-d295-b584-c8c0-6fde11397fea}">
+        <p14:section name="التوفير" id="{7fc6370a-b229-f019-4db9-cfc1e6e3abaa}">
           <p14:sldIdLst>
             <p14:sldId id="271"/>
             <p14:sldId id="272"/>
           </p14:sldIdLst>
         </p14:section>
-        <p14:section name="العمل معنا" id="{971097bd-72de-05c5-99df-d81d0856c3d2}">
+        <p14:section name="العمل معنا" id="{023f7fac-dcac-8bec-4c4b-71d90711a070}">
           <p14:sldIdLst>
             <p14:sldId id="273"/>
             <p14:sldId id="274"/>
@@ -11599,7 +11599,7 @@
       </p:sp>
       <p:pic>
         <p:nvPicPr>
-          <p:cNvPr id="5" name="photo-abdallah" descr="عبدالله دبان">    </p:cNvPr>
+          <p:cNvPr id="5" name="photo-abdallah" descr="عبدالله ضبان">    </p:cNvPr>
           <p:cNvPicPr>
             <a:picLocks noChangeAspect="1"/>
           </p:cNvPicPr>
@@ -11654,7 +11654,7 @@
                 <a:ea typeface="IBM Plex Sans Arabic" pitchFamily="34" charset="-122"/>
                 <a:cs typeface="IBM Plex Sans Arabic" pitchFamily="34" charset="-120"/>
               </a:rPr>
-              <a:t>عبدالله دبان</a:t>
+              <a:t>عبدالله ضبان</a:t>
             </a:r>
             <a:endParaRPr lang="en-US" sz="1800" dirty="0"/>
           </a:p>
@@ -11915,7 +11915,7 @@
       </p:sp>
       <p:pic>
         <p:nvPicPr>
-          <p:cNvPr id="15" name="photo-faisal" descr="فيصل قاسم">    </p:cNvPr>
+          <p:cNvPr id="15" name="photo-faisal" descr="فيصل شريف">    </p:cNvPr>
           <p:cNvPicPr>
             <a:picLocks noChangeAspect="1"/>
           </p:cNvPicPr>
@@ -11970,7 +11970,7 @@
                 <a:ea typeface="IBM Plex Sans Arabic" pitchFamily="34" charset="-122"/>
                 <a:cs typeface="IBM Plex Sans Arabic" pitchFamily="34" charset="-120"/>
               </a:rPr>
-              <a:t>فيصل قاسم</a:t>
+              <a:t>فيصل شريف</a:t>
             </a:r>
             <a:endParaRPr lang="en-US" sz="1800" dirty="0"/>
           </a:p>

</xml_diff>

<commit_message>
Profile: alternating backgrounds, logo opposite the title, names, document reminders
Even-numbered slides use a deeper sky-blue background so pages stay
distinct when the PDF is scrolled on a phone. The logo moves to the side
opposite the title on every layout (template included). Founder names
updated, and document follow-ups with automatic reminders added to the
overview, maintenance, savings and Saudi slides.

Co-Authored-By: Claude Opus 5.5 <noreply@anthropic.com>
Claude-Session: https://claude.ai/code/session_015T4Ky8TkjrkT1kBowiQKVz
</commit_message>
<xml_diff>
--- a/fleetana-launch/brand/profile/Fleetana-Company-Profile-AR.pptx
+++ b/fleetana-launch/brand/profile/Fleetana-Company-Profile-AR.pptx
@@ -126,20 +126,20 @@
   <p:extLst>
     <p:ext uri="{521415D9-36F7-43E2-AB2F-B90AF26B5E84}">
       <p14:sectionLst xmlns:p14="http://schemas.microsoft.com/office/powerpoint/2010/main">
-        <p14:section name="من نحن" id="{ad9eec1e-00cc-dc2d-be3d-70b6fdbcd315}">
+        <p14:section name="من نحن" id="{a4370ca8-c768-29f0-c962-4baea573d417}">
           <p14:sldIdLst>
             <p14:sldId id="256"/>
             <p14:sldId id="257"/>
             <p14:sldId id="258"/>
           </p14:sldIdLst>
         </p14:section>
-        <p14:section name="المشكلة" id="{bed8a8db-4aeb-ef97-360e-c7803c08a1f3}">
+        <p14:section name="المشكلة" id="{c00d71f9-8c3f-688a-a7c9-ccb574fd53cf}">
           <p14:sldIdLst>
             <p14:sldId id="259"/>
             <p14:sldId id="260"/>
           </p14:sldIdLst>
         </p14:section>
-        <p14:section name="الحل" id="{802bccb6-4771-9157-e82f-036942c27e99}">
+        <p14:section name="الحل" id="{017d4434-4c80-0992-94d6-07a93982c814}">
           <p14:sldIdLst>
             <p14:sldId id="261"/>
             <p14:sldId id="262"/>
@@ -150,20 +150,20 @@
             <p14:sldId id="267"/>
           </p14:sldIdLst>
         </p14:section>
-        <p14:section name="أجهزة التتبع" id="{167f20a3-c95b-d774-4076-07c63d30a3f9}">
+        <p14:section name="أجهزة التتبع" id="{c357a473-8ff4-3092-b189-f3edcb0b6932}">
           <p14:sldIdLst>
             <p14:sldId id="268"/>
             <p14:sldId id="269"/>
             <p14:sldId id="270"/>
           </p14:sldIdLst>
         </p14:section>
-        <p14:section name="التوفير" id="{7fc6370a-b229-f019-4db9-cfc1e6e3abaa}">
+        <p14:section name="التوفير" id="{d9a073b6-85d4-5858-95dd-11032d81be6f}">
           <p14:sldIdLst>
             <p14:sldId id="271"/>
             <p14:sldId id="272"/>
           </p14:sldIdLst>
         </p14:section>
-        <p14:section name="العمل معنا" id="{023f7fac-dcac-8bec-4c4b-71d90711a070}">
+        <p14:section name="العمل معنا" id="{654c05a1-be46-44c8-28ce-fbe9f450de9d}">
           <p14:sldIdLst>
             <p14:sldId id="273"/>
             <p14:sldId id="274"/>
@@ -2365,7 +2365,7 @@
         </p:blipFill>
         <p:spPr>
           <a:xfrm>
-            <a:off x="8851026" y="548640"/>
+            <a:off x="548640" y="548640"/>
             <a:ext cx="2792029" cy="384048"/>
           </a:xfrm>
           <a:prstGeom prst="rect">
@@ -2590,7 +2590,7 @@
         </p:blipFill>
         <p:spPr>
           <a:xfrm>
-            <a:off x="9914656" y="384048"/>
+            <a:off x="548640" y="384048"/>
             <a:ext cx="1728399" cy="237744"/>
           </a:xfrm>
           <a:prstGeom prst="rect">
@@ -2847,7 +2847,7 @@
         </p:blipFill>
         <p:spPr>
           <a:xfrm>
-            <a:off x="9914656" y="384048"/>
+            <a:off x="548640" y="384048"/>
             <a:ext cx="1728399" cy="237744"/>
           </a:xfrm>
           <a:prstGeom prst="rect">
@@ -3023,7 +3023,7 @@
         </p:blipFill>
         <p:spPr>
           <a:xfrm>
-            <a:off x="9914656" y="384048"/>
+            <a:off x="548640" y="384048"/>
             <a:ext cx="1728399" cy="237744"/>
           </a:xfrm>
           <a:prstGeom prst="rect">
@@ -3930,6 +3930,13 @@
 <file path=ppt/slides/slide10.xml><?xml version="1.0" encoding="utf-8"?>
 <p:sld xmlns:a="http://schemas.openxmlformats.org/drawingml/2006/main" xmlns:r="http://schemas.openxmlformats.org/officeDocument/2006/relationships" xmlns:p="http://schemas.openxmlformats.org/presentationml/2006/main">
   <p:cSld name="Slide 10">
+    <p:bg>
+      <p:bgPr>
+        <a:solidFill>
+          <a:srgbClr val="DCEAFB"/>
+        </a:solidFill>
+      </p:bgPr>
+    </p:bg>
     <p:spTree>
       <p:nvGrpSpPr>
         <p:cNvPr id="1" name=""/>
@@ -5121,6 +5128,13 @@
 <file path=ppt/slides/slide12.xml><?xml version="1.0" encoding="utf-8"?>
 <p:sld xmlns:a="http://schemas.openxmlformats.org/drawingml/2006/main" xmlns:r="http://schemas.openxmlformats.org/officeDocument/2006/relationships" xmlns:p="http://schemas.openxmlformats.org/presentationml/2006/main">
   <p:cSld name="Slide 12">
+    <p:bg>
+      <p:bgPr>
+        <a:solidFill>
+          <a:srgbClr val="DCEAFB"/>
+        </a:solidFill>
+      </p:bgPr>
+    </p:bg>
     <p:spTree>
       <p:nvGrpSpPr>
         <p:cNvPr id="1" name=""/>
@@ -5294,6 +5308,24 @@
                 </a:solidFill>
               </a:rPr>
               <a:t>مخزون القطع لكل موقع، وفترات الضمان على القطع والإصلاحات</a:t>
+            </a:r>
+            <a:endParaRPr lang="en-US" sz="1600" dirty="0"/>
+          </a:p>
+          <a:p>
+            <a:pPr rtl="1" algn="r" marL="342900" indent="-342900">
+              <a:spcAft>
+                <a:spcPts val="1000"/>
+              </a:spcAft>
+              <a:buSzPct val="100000"/>
+              <a:buChar char="●"/>
+            </a:pPr>
+            <a:r>
+              <a:rPr lang="en-US" sz="1600" dirty="0">
+                <a:solidFill>
+                  <a:srgbClr val="0F172A"/>
+                </a:solidFill>
+              </a:rPr>
+              <a:t>إشعارات تلقائية قبل كل صيانة وفحص وتجديد وثيقة</a:t>
             </a:r>
             <a:endParaRPr lang="en-US" sz="1600" dirty="0"/>
           </a:p>
@@ -5471,6 +5503,20 @@
 <file path=ppt/slides/slide13.xml><?xml version="1.0" encoding="utf-8"?>
 <p:sld xmlns:a="http://schemas.openxmlformats.org/drawingml/2006/main" xmlns:r="http://schemas.openxmlformats.org/officeDocument/2006/relationships" xmlns:p="http://schemas.openxmlformats.org/presentationml/2006/main">
   <p:cSld name="Slide 13">
+    <p:bg>
+      <p:bgPr>
+        <a:blipFill dpi="0" rotWithShape="1">
+          <a:blip r:embed="rId1">
+            <a:lum/>
+          </a:blip>
+          <a:srcRect/>
+          <a:stretch>
+            <a:fillRect/>
+          </a:stretch>
+        </a:blipFill>
+        <a:effectLst/>
+      </p:bgPr>
+    </p:bg>
     <p:spTree>
       <p:nvGrpSpPr>
         <p:cNvPr id="1" name=""/>
@@ -5658,6 +5704,13 @@
 <file path=ppt/slides/slide14.xml><?xml version="1.0" encoding="utf-8"?>
 <p:sld xmlns:a="http://schemas.openxmlformats.org/drawingml/2006/main" xmlns:r="http://schemas.openxmlformats.org/officeDocument/2006/relationships" xmlns:p="http://schemas.openxmlformats.org/presentationml/2006/main">
   <p:cSld name="Slide 14">
+    <p:bg>
+      <p:bgPr>
+        <a:solidFill>
+          <a:srgbClr val="DCEAFB"/>
+        </a:solidFill>
+      </p:bgPr>
+    </p:bg>
     <p:spTree>
       <p:nvGrpSpPr>
         <p:cNvPr id="1" name=""/>
@@ -8873,6 +8926,13 @@
 <file path=ppt/slides/slide16.xml><?xml version="1.0" encoding="utf-8"?>
 <p:sld xmlns:a="http://schemas.openxmlformats.org/drawingml/2006/main" xmlns:r="http://schemas.openxmlformats.org/officeDocument/2006/relationships" xmlns:p="http://schemas.openxmlformats.org/presentationml/2006/main">
   <p:cSld name="Slide 16">
+    <p:bg>
+      <p:bgPr>
+        <a:solidFill>
+          <a:srgbClr val="DCEAFB"/>
+        </a:solidFill>
+      </p:bgPr>
+    </p:bg>
     <p:spTree>
       <p:nvGrpSpPr>
         <p:cNvPr id="1" name=""/>
@@ -9527,7 +9587,7 @@
                   <a:srgbClr val="45464D"/>
                 </a:solidFill>
               </a:rPr>
-              <a:t>وثائق سارية دائمًا</a:t>
+              <a:t>تذكير تلقائي قبل انتهاء الوثائق</a:t>
             </a:r>
             <a:endParaRPr lang="en-US" sz="1300" dirty="0"/>
           </a:p>
@@ -10584,7 +10644,7 @@
                   <a:srgbClr val="45464D"/>
                 </a:solidFill>
               </a:rPr>
-              <a:t>تواريخ الانتهاء محفوظة في سجل كل مركبة، والرئيسية تعرض ما ينتهي خلال 30 يومًا.</a:t>
+              <a:t>يتابع فليتانا كل وثيقة ويُشعرك قبل انتهاء الاستمارة والتأمين والفحص الدوري.</a:t>
             </a:r>
             <a:endParaRPr lang="en-US" sz="1250" dirty="0"/>
           </a:p>
@@ -10646,6 +10706,13 @@
 <file path=ppt/slides/slide18.xml><?xml version="1.0" encoding="utf-8"?>
 <p:sld xmlns:a="http://schemas.openxmlformats.org/drawingml/2006/main" xmlns:r="http://schemas.openxmlformats.org/officeDocument/2006/relationships" xmlns:p="http://schemas.openxmlformats.org/presentationml/2006/main">
   <p:cSld name="Slide 18">
+    <p:bg>
+      <p:bgPr>
+        <a:solidFill>
+          <a:srgbClr val="DCEAFB"/>
+        </a:solidFill>
+      </p:bgPr>
+    </p:bg>
     <p:spTree>
       <p:nvGrpSpPr>
         <p:cNvPr id="1" name=""/>
@@ -11915,7 +11982,7 @@
       </p:sp>
       <p:pic>
         <p:nvPicPr>
-          <p:cNvPr id="15" name="photo-faisal" descr="فيصل شريف">    </p:cNvPr>
+          <p:cNvPr id="15" name="photo-faisal" descr="فيصل الشريف">    </p:cNvPr>
           <p:cNvPicPr>
             <a:picLocks noChangeAspect="1"/>
           </p:cNvPicPr>
@@ -11970,7 +12037,7 @@
                 <a:ea typeface="IBM Plex Sans Arabic" pitchFamily="34" charset="-122"/>
                 <a:cs typeface="IBM Plex Sans Arabic" pitchFamily="34" charset="-120"/>
               </a:rPr>
-              <a:t>فيصل شريف</a:t>
+              <a:t>فيصل الشريف</a:t>
             </a:r>
             <a:endParaRPr lang="en-US" sz="1800" dirty="0"/>
           </a:p>
@@ -12226,6 +12293,13 @@
 <file path=ppt/slides/slide2.xml><?xml version="1.0" encoding="utf-8"?>
 <p:sld xmlns:a="http://schemas.openxmlformats.org/drawingml/2006/main" xmlns:r="http://schemas.openxmlformats.org/officeDocument/2006/relationships" xmlns:p="http://schemas.openxmlformats.org/presentationml/2006/main">
   <p:cSld name="Slide 2">
+    <p:bg>
+      <p:bgPr>
+        <a:solidFill>
+          <a:srgbClr val="DCEAFB"/>
+        </a:solidFill>
+      </p:bgPr>
+    </p:bg>
     <p:spTree>
       <p:nvGrpSpPr>
         <p:cNvPr id="1" name=""/>
@@ -12917,6 +12991,20 @@
 <file path=ppt/slides/slide20.xml><?xml version="1.0" encoding="utf-8"?>
 <p:sld xmlns:a="http://schemas.openxmlformats.org/drawingml/2006/main" xmlns:r="http://schemas.openxmlformats.org/officeDocument/2006/relationships" xmlns:p="http://schemas.openxmlformats.org/presentationml/2006/main">
   <p:cSld name="Slide 20">
+    <p:bg>
+      <p:bgPr>
+        <a:blipFill dpi="0" rotWithShape="1">
+          <a:blip r:embed="rId1">
+            <a:lum/>
+          </a:blip>
+          <a:srcRect/>
+          <a:stretch>
+            <a:fillRect/>
+          </a:stretch>
+        </a:blipFill>
+        <a:effectLst/>
+      </p:bgPr>
+    </p:bg>
     <p:spTree>
       <p:nvGrpSpPr>
         <p:cNvPr id="1" name=""/>
@@ -15285,6 +15373,13 @@
 <file path=ppt/slides/slide8.xml><?xml version="1.0" encoding="utf-8"?>
 <p:sld xmlns:a="http://schemas.openxmlformats.org/drawingml/2006/main" xmlns:r="http://schemas.openxmlformats.org/officeDocument/2006/relationships" xmlns:p="http://schemas.openxmlformats.org/presentationml/2006/main">
   <p:cSld name="Slide 8">
+    <p:bg>
+      <p:bgPr>
+        <a:solidFill>
+          <a:srgbClr val="DCEAFB"/>
+        </a:solidFill>
+      </p:bgPr>
+    </p:bg>
     <p:spTree>
       <p:nvGrpSpPr>
         <p:cNvPr id="1" name=""/>
@@ -15503,7 +15598,7 @@
                   <a:srgbClr val="45464D"/>
                 </a:solidFill>
               </a:rPr>
-              <a:t>اللوحات والسائقون والاستمارة والتأمين والفحص الدوري لكل مركبة.</a:t>
+              <a:t>الاستمارة والتأمين والفحص الدوري، مع تذكيرات تلقائية قبل كل انتهاء.</a:t>
             </a:r>
             <a:endParaRPr lang="en-US" sz="1300" dirty="0"/>
           </a:p>

</xml_diff>